<commit_message>
docs: deck v3 corrections (Portabilidad de Entrada, alternative 1 wording, slide 2 title) and backing document
Co-Authored-By: Claude Fable 5.1 <noreply@anthropic.com>
Claude-Session: https://claude.ai/code/session_01EdiFW99rh4cyUjRbojqkjk
</commit_message>
<xml_diff>
--- a/docs/benchmarking/infografia-2020-vs-hoy.pptx
+++ b/docs/benchmarking/infografia-2020-vs-hoy.pptx
@@ -1079,7 +1079,7 @@
                 <a:ea typeface="Cambria" pitchFamily="34" charset="-122"/>
                 <a:cs typeface="Cambria" pitchFamily="34" charset="-120"/>
               </a:rPr>
-              <a:t>El trabajo cambió, la escala no: de Contabilidad de Entrada a Especialista Normativo</a:t>
+              <a:t>El trabajo cambió, la escala no: de Portabilidad de Entrada a Especialista Normativo</a:t>
             </a:r>
             <a:endParaRPr lang="en-US" sz="1700" dirty="0"/>
           </a:p>
@@ -1168,7 +1168,7 @@
                 <a:ea typeface="Cambria" pitchFamily="34" charset="-122"/>
                 <a:cs typeface="Cambria" pitchFamily="34" charset="-120"/>
               </a:rPr>
-              <a:t>Analista de Contabilidad de Entrada (Portabilidad Financiera)</a:t>
+              <a:t>Analista de Portabilidad de Entrada</a:t>
             </a:r>
             <a:endParaRPr lang="en-US" sz="750" dirty="0"/>
           </a:p>
@@ -1948,7 +1948,7 @@
                 <a:ea typeface="Calibri" pitchFamily="34" charset="-122"/>
                 <a:cs typeface="Calibri" pitchFamily="34" charset="-120"/>
               </a:rPr>
-              <a:t>7</a:t>
+              <a:t>10</a:t>
             </a:r>
             <a:endParaRPr lang="en-US" sz="1500" dirty="0"/>
           </a:p>
@@ -3284,7 +3284,7 @@
                 <a:ea typeface="Calibri" pitchFamily="34" charset="-122"/>
                 <a:cs typeface="Calibri" pitchFamily="34" charset="-120"/>
               </a:rPr>
-              <a:t>Power BI y DAX</a:t>
+              <a:t>Power BI</a:t>
             </a:r>
             <a:endParaRPr lang="en-US" sz="850" dirty="0"/>
           </a:p>
@@ -5541,12 +5541,12 @@
         </p:nvSpPr>
         <p:spPr>
           <a:xfrm>
-            <a:off x="8522208" y="2743200"/>
-            <a:ext cx="3191256" cy="182880"/>
+            <a:off x="8522208" y="2734056"/>
+            <a:ext cx="3191256" cy="173736"/>
           </a:xfrm>
           <a:prstGeom prst="roundRect">
             <a:avLst>
-              <a:gd name="adj" fmla="val 20000"/>
+              <a:gd name="adj" fmla="val 21053"/>
             </a:avLst>
           </a:prstGeom>
           <a:solidFill>
@@ -5568,8 +5568,8 @@
         </p:nvSpPr>
         <p:spPr>
           <a:xfrm>
-            <a:off x="8577072" y="2743200"/>
-            <a:ext cx="3081528" cy="182880"/>
+            <a:off x="8577072" y="2734056"/>
+            <a:ext cx="3081528" cy="173736"/>
           </a:xfrm>
           <a:prstGeom prst="rect">
             <a:avLst/>
@@ -5607,12 +5607,12 @@
         </p:nvSpPr>
         <p:spPr>
           <a:xfrm>
-            <a:off x="8522208" y="2962656"/>
-            <a:ext cx="3191256" cy="182880"/>
+            <a:off x="8522208" y="2935224"/>
+            <a:ext cx="3191256" cy="173736"/>
           </a:xfrm>
           <a:prstGeom prst="roundRect">
             <a:avLst>
-              <a:gd name="adj" fmla="val 20000"/>
+              <a:gd name="adj" fmla="val 21053"/>
             </a:avLst>
           </a:prstGeom>
           <a:solidFill>
@@ -5634,8 +5634,8 @@
         </p:nvSpPr>
         <p:spPr>
           <a:xfrm>
-            <a:off x="8577072" y="2962656"/>
-            <a:ext cx="3081528" cy="182880"/>
+            <a:off x="8577072" y="2935224"/>
+            <a:ext cx="3081528" cy="173736"/>
           </a:xfrm>
           <a:prstGeom prst="rect">
             <a:avLst/>
@@ -5673,12 +5673,12 @@
         </p:nvSpPr>
         <p:spPr>
           <a:xfrm>
-            <a:off x="8522208" y="3182112"/>
-            <a:ext cx="3191256" cy="182880"/>
+            <a:off x="8522208" y="3136392"/>
+            <a:ext cx="3191256" cy="173736"/>
           </a:xfrm>
           <a:prstGeom prst="roundRect">
             <a:avLst>
-              <a:gd name="adj" fmla="val 20000"/>
+              <a:gd name="adj" fmla="val 21053"/>
             </a:avLst>
           </a:prstGeom>
           <a:solidFill>
@@ -5700,8 +5700,8 @@
         </p:nvSpPr>
         <p:spPr>
           <a:xfrm>
-            <a:off x="8577072" y="3182112"/>
-            <a:ext cx="3081528" cy="182880"/>
+            <a:off x="8577072" y="3136392"/>
+            <a:ext cx="3081528" cy="173736"/>
           </a:xfrm>
           <a:prstGeom prst="rect">
             <a:avLst/>
@@ -5739,12 +5739,12 @@
         </p:nvSpPr>
         <p:spPr>
           <a:xfrm>
-            <a:off x="8522208" y="3401568"/>
-            <a:ext cx="3191256" cy="182880"/>
+            <a:off x="8522208" y="3337560"/>
+            <a:ext cx="3191256" cy="173736"/>
           </a:xfrm>
           <a:prstGeom prst="roundRect">
             <a:avLst>
-              <a:gd name="adj" fmla="val 20000"/>
+              <a:gd name="adj" fmla="val 21053"/>
             </a:avLst>
           </a:prstGeom>
           <a:solidFill>
@@ -5766,8 +5766,8 @@
         </p:nvSpPr>
         <p:spPr>
           <a:xfrm>
-            <a:off x="8577072" y="3401568"/>
-            <a:ext cx="3081528" cy="182880"/>
+            <a:off x="8577072" y="3337560"/>
+            <a:ext cx="3081528" cy="173736"/>
           </a:xfrm>
           <a:prstGeom prst="rect">
             <a:avLst/>
@@ -5805,12 +5805,12 @@
         </p:nvSpPr>
         <p:spPr>
           <a:xfrm>
-            <a:off x="8522208" y="3621024"/>
-            <a:ext cx="3191256" cy="182880"/>
+            <a:off x="8522208" y="3538728"/>
+            <a:ext cx="3191256" cy="173736"/>
           </a:xfrm>
           <a:prstGeom prst="roundRect">
             <a:avLst>
-              <a:gd name="adj" fmla="val 20000"/>
+              <a:gd name="adj" fmla="val 21053"/>
             </a:avLst>
           </a:prstGeom>
           <a:solidFill>
@@ -5832,8 +5832,8 @@
         </p:nvSpPr>
         <p:spPr>
           <a:xfrm>
-            <a:off x="8577072" y="3621024"/>
-            <a:ext cx="3081528" cy="182880"/>
+            <a:off x="8577072" y="3538728"/>
+            <a:ext cx="3081528" cy="173736"/>
           </a:xfrm>
           <a:prstGeom prst="rect">
             <a:avLst/>
@@ -5871,12 +5871,12 @@
         </p:nvSpPr>
         <p:spPr>
           <a:xfrm>
-            <a:off x="8522208" y="3840480"/>
-            <a:ext cx="3191256" cy="182880"/>
+            <a:off x="8522208" y="3739896"/>
+            <a:ext cx="3191256" cy="173736"/>
           </a:xfrm>
           <a:prstGeom prst="roundRect">
             <a:avLst>
-              <a:gd name="adj" fmla="val 20000"/>
+              <a:gd name="adj" fmla="val 21053"/>
             </a:avLst>
           </a:prstGeom>
           <a:solidFill>
@@ -5898,8 +5898,8 @@
         </p:nvSpPr>
         <p:spPr>
           <a:xfrm>
-            <a:off x="8577072" y="3840480"/>
-            <a:ext cx="3081528" cy="182880"/>
+            <a:off x="8577072" y="3739896"/>
+            <a:ext cx="3081528" cy="173736"/>
           </a:xfrm>
           <a:prstGeom prst="rect">
             <a:avLst/>
@@ -5937,12 +5937,12 @@
         </p:nvSpPr>
         <p:spPr>
           <a:xfrm>
-            <a:off x="8522208" y="4059936"/>
-            <a:ext cx="3191256" cy="182880"/>
+            <a:off x="8522208" y="3941064"/>
+            <a:ext cx="3191256" cy="173736"/>
           </a:xfrm>
           <a:prstGeom prst="roundRect">
             <a:avLst>
-              <a:gd name="adj" fmla="val 20000"/>
+              <a:gd name="adj" fmla="val 21053"/>
             </a:avLst>
           </a:prstGeom>
           <a:solidFill>
@@ -5964,8 +5964,8 @@
         </p:nvSpPr>
         <p:spPr>
           <a:xfrm>
-            <a:off x="8577072" y="4059936"/>
-            <a:ext cx="3081528" cy="182880"/>
+            <a:off x="8577072" y="3941064"/>
+            <a:ext cx="3081528" cy="173736"/>
           </a:xfrm>
           <a:prstGeom prst="rect">
             <a:avLst/>
@@ -6003,7 +6003,7 @@
         </p:nvSpPr>
         <p:spPr>
           <a:xfrm>
-            <a:off x="8522208" y="4315968"/>
+            <a:off x="8522208" y="4178808"/>
             <a:ext cx="3191256" cy="182880"/>
           </a:xfrm>
           <a:prstGeom prst="rect">
@@ -6056,12 +6056,12 @@
         </p:nvSpPr>
         <p:spPr>
           <a:xfrm>
-            <a:off x="8522208" y="4517136"/>
-            <a:ext cx="770382" cy="182880"/>
+            <a:off x="8522208" y="4370832"/>
+            <a:ext cx="777240" cy="173736"/>
           </a:xfrm>
           <a:prstGeom prst="roundRect">
             <a:avLst>
-              <a:gd name="adj" fmla="val 20000"/>
+              <a:gd name="adj" fmla="val 21053"/>
             </a:avLst>
           </a:prstGeom>
           <a:solidFill>
@@ -6083,8 +6083,8 @@
         </p:nvSpPr>
         <p:spPr>
           <a:xfrm>
-            <a:off x="8577072" y="4517136"/>
-            <a:ext cx="660654" cy="182880"/>
+            <a:off x="8577072" y="4370832"/>
+            <a:ext cx="667512" cy="173736"/>
           </a:xfrm>
           <a:prstGeom prst="rect">
             <a:avLst/>
@@ -6100,7 +6100,7 @@
               <a:buNone/>
             </a:pPr>
             <a:r>
-              <a:rPr lang="en-US" sz="750" b="1" dirty="0">
+              <a:rPr lang="en-US" sz="700" b="1" dirty="0">
                 <a:solidFill>
                   <a:srgbClr val="1C5CAB"/>
                 </a:solidFill>
@@ -6108,9 +6108,9 @@
                 <a:ea typeface="Calibri" pitchFamily="34" charset="-122"/>
                 <a:cs typeface="Calibri" pitchFamily="34" charset="-120"/>
               </a:rPr>
-              <a:t>DAX</a:t>
-            </a:r>
-            <a:endParaRPr lang="en-US" sz="750" dirty="0"/>
+              <a:t>Power BI</a:t>
+            </a:r>
+            <a:endParaRPr lang="en-US" sz="700" dirty="0"/>
           </a:p>
         </p:txBody>
       </p:sp>
@@ -6122,12 +6122,12 @@
         </p:nvSpPr>
         <p:spPr>
           <a:xfrm>
-            <a:off x="9329166" y="4517136"/>
-            <a:ext cx="770382" cy="182880"/>
+            <a:off x="9326880" y="4370832"/>
+            <a:ext cx="777240" cy="173736"/>
           </a:xfrm>
           <a:prstGeom prst="roundRect">
             <a:avLst>
-              <a:gd name="adj" fmla="val 20000"/>
+              <a:gd name="adj" fmla="val 21053"/>
             </a:avLst>
           </a:prstGeom>
           <a:solidFill>
@@ -6149,8 +6149,8 @@
         </p:nvSpPr>
         <p:spPr>
           <a:xfrm>
-            <a:off x="9384030" y="4517136"/>
-            <a:ext cx="660654" cy="182880"/>
+            <a:off x="9381744" y="4370832"/>
+            <a:ext cx="667512" cy="173736"/>
           </a:xfrm>
           <a:prstGeom prst="rect">
             <a:avLst/>
@@ -6166,7 +6166,7 @@
               <a:buNone/>
             </a:pPr>
             <a:r>
-              <a:rPr lang="en-US" sz="750" b="1" dirty="0">
+              <a:rPr lang="en-US" sz="700" b="1" dirty="0">
                 <a:solidFill>
                   <a:srgbClr val="1C5CAB"/>
                 </a:solidFill>
@@ -6176,7 +6176,7 @@
               </a:rPr>
               <a:t>SQL</a:t>
             </a:r>
-            <a:endParaRPr lang="en-US" sz="750" dirty="0"/>
+            <a:endParaRPr lang="en-US" sz="700" dirty="0"/>
           </a:p>
         </p:txBody>
       </p:sp>
@@ -6188,12 +6188,12 @@
         </p:nvSpPr>
         <p:spPr>
           <a:xfrm>
-            <a:off x="10136124" y="4517136"/>
-            <a:ext cx="770382" cy="182880"/>
+            <a:off x="10131552" y="4370832"/>
+            <a:ext cx="777240" cy="173736"/>
           </a:xfrm>
           <a:prstGeom prst="roundRect">
             <a:avLst>
-              <a:gd name="adj" fmla="val 20000"/>
+              <a:gd name="adj" fmla="val 21053"/>
             </a:avLst>
           </a:prstGeom>
           <a:solidFill>
@@ -6215,8 +6215,8 @@
         </p:nvSpPr>
         <p:spPr>
           <a:xfrm>
-            <a:off x="10190988" y="4517136"/>
-            <a:ext cx="660654" cy="182880"/>
+            <a:off x="10186416" y="4370832"/>
+            <a:ext cx="667512" cy="173736"/>
           </a:xfrm>
           <a:prstGeom prst="rect">
             <a:avLst/>
@@ -6232,7 +6232,7 @@
               <a:buNone/>
             </a:pPr>
             <a:r>
-              <a:rPr lang="en-US" sz="750" b="1" dirty="0">
+              <a:rPr lang="en-US" sz="700" b="1" dirty="0">
                 <a:solidFill>
                   <a:srgbClr val="1C5CAB"/>
                 </a:solidFill>
@@ -6242,7 +6242,7 @@
               </a:rPr>
               <a:t>Access</a:t>
             </a:r>
-            <a:endParaRPr lang="en-US" sz="750" dirty="0"/>
+            <a:endParaRPr lang="en-US" sz="700" dirty="0"/>
           </a:p>
         </p:txBody>
       </p:sp>
@@ -6254,12 +6254,12 @@
         </p:nvSpPr>
         <p:spPr>
           <a:xfrm>
-            <a:off x="10943082" y="4517136"/>
-            <a:ext cx="770382" cy="182880"/>
+            <a:off x="10936224" y="4370832"/>
+            <a:ext cx="777240" cy="173736"/>
           </a:xfrm>
           <a:prstGeom prst="roundRect">
             <a:avLst>
-              <a:gd name="adj" fmla="val 20000"/>
+              <a:gd name="adj" fmla="val 21053"/>
             </a:avLst>
           </a:prstGeom>
           <a:solidFill>
@@ -6281,8 +6281,8 @@
         </p:nvSpPr>
         <p:spPr>
           <a:xfrm>
-            <a:off x="10997946" y="4517136"/>
-            <a:ext cx="660654" cy="182880"/>
+            <a:off x="10991088" y="4370832"/>
+            <a:ext cx="667512" cy="173736"/>
           </a:xfrm>
           <a:prstGeom prst="rect">
             <a:avLst/>
@@ -6298,7 +6298,7 @@
               <a:buNone/>
             </a:pPr>
             <a:r>
-              <a:rPr lang="en-US" sz="750" b="1" dirty="0">
+              <a:rPr lang="en-US" sz="700" b="1" dirty="0">
                 <a:solidFill>
                   <a:srgbClr val="1C5CAB"/>
                 </a:solidFill>
@@ -6308,7 +6308,7 @@
               </a:rPr>
               <a:t>Agile</a:t>
             </a:r>
-            <a:endParaRPr lang="en-US" sz="750" dirty="0"/>
+            <a:endParaRPr lang="en-US" sz="700" dirty="0"/>
           </a:p>
         </p:txBody>
       </p:sp>
@@ -6320,12 +6320,12 @@
         </p:nvSpPr>
         <p:spPr>
           <a:xfrm>
-            <a:off x="8522208" y="4736592"/>
-            <a:ext cx="770382" cy="182880"/>
+            <a:off x="8522208" y="4572000"/>
+            <a:ext cx="777240" cy="173736"/>
           </a:xfrm>
           <a:prstGeom prst="roundRect">
             <a:avLst>
-              <a:gd name="adj" fmla="val 20000"/>
+              <a:gd name="adj" fmla="val 21053"/>
             </a:avLst>
           </a:prstGeom>
           <a:solidFill>
@@ -6347,8 +6347,8 @@
         </p:nvSpPr>
         <p:spPr>
           <a:xfrm>
-            <a:off x="8577072" y="4736592"/>
-            <a:ext cx="660654" cy="182880"/>
+            <a:off x="8577072" y="4572000"/>
+            <a:ext cx="667512" cy="173736"/>
           </a:xfrm>
           <a:prstGeom prst="rect">
             <a:avLst/>
@@ -6364,7 +6364,7 @@
               <a:buNone/>
             </a:pPr>
             <a:r>
-              <a:rPr lang="en-US" sz="750" b="1" dirty="0">
+              <a:rPr lang="en-US" sz="700" b="1" dirty="0">
                 <a:solidFill>
                   <a:srgbClr val="1C5CAB"/>
                 </a:solidFill>
@@ -6374,7 +6374,7 @@
               </a:rPr>
               <a:t>Analítica</a:t>
             </a:r>
-            <a:endParaRPr lang="en-US" sz="750" dirty="0"/>
+            <a:endParaRPr lang="en-US" sz="700" dirty="0"/>
           </a:p>
         </p:txBody>
       </p:sp>
@@ -6386,12 +6386,12 @@
         </p:nvSpPr>
         <p:spPr>
           <a:xfrm>
-            <a:off x="9329166" y="4736592"/>
-            <a:ext cx="770382" cy="182880"/>
+            <a:off x="9326880" y="4572000"/>
+            <a:ext cx="777240" cy="173736"/>
           </a:xfrm>
           <a:prstGeom prst="roundRect">
             <a:avLst>
-              <a:gd name="adj" fmla="val 20000"/>
+              <a:gd name="adj" fmla="val 21053"/>
             </a:avLst>
           </a:prstGeom>
           <a:solidFill>
@@ -6413,8 +6413,8 @@
         </p:nvSpPr>
         <p:spPr>
           <a:xfrm>
-            <a:off x="9384030" y="4736592"/>
-            <a:ext cx="660654" cy="182880"/>
+            <a:off x="9381744" y="4572000"/>
+            <a:ext cx="667512" cy="173736"/>
           </a:xfrm>
           <a:prstGeom prst="rect">
             <a:avLst/>
@@ -6430,7 +6430,7 @@
               <a:buNone/>
             </a:pPr>
             <a:r>
-              <a:rPr lang="en-US" sz="750" b="1" dirty="0">
+              <a:rPr lang="en-US" sz="700" b="1" dirty="0">
                 <a:solidFill>
                   <a:srgbClr val="1C5CAB"/>
                 </a:solidFill>
@@ -6440,7 +6440,7 @@
               </a:rPr>
               <a:t>Plazos</a:t>
             </a:r>
-            <a:endParaRPr lang="en-US" sz="750" dirty="0"/>
+            <a:endParaRPr lang="en-US" sz="700" dirty="0"/>
           </a:p>
         </p:txBody>
       </p:sp>
@@ -6452,12 +6452,12 @@
         </p:nvSpPr>
         <p:spPr>
           <a:xfrm>
-            <a:off x="10136124" y="4736592"/>
-            <a:ext cx="770382" cy="182880"/>
+            <a:off x="10131552" y="4572000"/>
+            <a:ext cx="777240" cy="173736"/>
           </a:xfrm>
           <a:prstGeom prst="roundRect">
             <a:avLst>
-              <a:gd name="adj" fmla="val 20000"/>
+              <a:gd name="adj" fmla="val 21053"/>
             </a:avLst>
           </a:prstGeom>
           <a:solidFill>
@@ -6479,8 +6479,8 @@
         </p:nvSpPr>
         <p:spPr>
           <a:xfrm>
-            <a:off x="10190988" y="4736592"/>
-            <a:ext cx="660654" cy="182880"/>
+            <a:off x="10186416" y="4572000"/>
+            <a:ext cx="667512" cy="173736"/>
           </a:xfrm>
           <a:prstGeom prst="rect">
             <a:avLst/>
@@ -6496,7 +6496,7 @@
               <a:buNone/>
             </a:pPr>
             <a:r>
-              <a:rPr lang="en-US" sz="750" b="1" dirty="0">
+              <a:rPr lang="en-US" sz="700" b="1" dirty="0">
                 <a:solidFill>
                   <a:srgbClr val="1C5CAB"/>
                 </a:solidFill>
@@ -6506,7 +6506,7 @@
               </a:rPr>
               <a:t>Databricks</a:t>
             </a:r>
-            <a:endParaRPr lang="en-US" sz="750" dirty="0"/>
+            <a:endParaRPr lang="en-US" sz="700" dirty="0"/>
           </a:p>
         </p:txBody>
       </p:sp>
@@ -6518,12 +6518,12 @@
         </p:nvSpPr>
         <p:spPr>
           <a:xfrm>
-            <a:off x="10943082" y="4736592"/>
-            <a:ext cx="770382" cy="182880"/>
+            <a:off x="10936224" y="4572000"/>
+            <a:ext cx="777240" cy="173736"/>
           </a:xfrm>
           <a:prstGeom prst="roundRect">
             <a:avLst>
-              <a:gd name="adj" fmla="val 20000"/>
+              <a:gd name="adj" fmla="val 21053"/>
             </a:avLst>
           </a:prstGeom>
           <a:solidFill>
@@ -6545,8 +6545,8 @@
         </p:nvSpPr>
         <p:spPr>
           <a:xfrm>
-            <a:off x="10997946" y="4736592"/>
-            <a:ext cx="660654" cy="182880"/>
+            <a:off x="10991088" y="4572000"/>
+            <a:ext cx="667512" cy="173736"/>
           </a:xfrm>
           <a:prstGeom prst="rect">
             <a:avLst/>
@@ -6562,7 +6562,7 @@
               <a:buNone/>
             </a:pPr>
             <a:r>
-              <a:rPr lang="en-US" sz="750" b="1" dirty="0">
+              <a:rPr lang="en-US" sz="700" b="1" dirty="0">
                 <a:solidFill>
                   <a:srgbClr val="1C5CAB"/>
                 </a:solidFill>
@@ -6572,7 +6572,7 @@
               </a:rPr>
               <a:t>Normas CMF</a:t>
             </a:r>
-            <a:endParaRPr lang="en-US" sz="750" dirty="0"/>
+            <a:endParaRPr lang="en-US" sz="700" dirty="0"/>
           </a:p>
         </p:txBody>
       </p:sp>
@@ -6584,7 +6584,7 @@
         </p:nvSpPr>
         <p:spPr>
           <a:xfrm>
-            <a:off x="8522208" y="4992624"/>
+            <a:off x="8522208" y="4809744"/>
             <a:ext cx="3191256" cy="182880"/>
           </a:xfrm>
           <a:prstGeom prst="rect">
@@ -6623,7 +6623,7 @@
                 <a:ea typeface="Courier New" pitchFamily="34" charset="-122"/>
                 <a:cs typeface="Courier New" pitchFamily="34" charset="-120"/>
               </a:rPr>
-              <a:t>+4</a:t>
+              <a:t>+7</a:t>
             </a:r>
             <a:endParaRPr lang="en-US" sz="1000" dirty="0"/>
           </a:p>
@@ -6637,12 +6637,12 @@
         </p:nvSpPr>
         <p:spPr>
           <a:xfrm>
-            <a:off x="8522208" y="5193792"/>
-            <a:ext cx="1577340" cy="182880"/>
+            <a:off x="8522208" y="5001768"/>
+            <a:ext cx="1045464" cy="173736"/>
           </a:xfrm>
           <a:prstGeom prst="roundRect">
             <a:avLst>
-              <a:gd name="adj" fmla="val 20000"/>
+              <a:gd name="adj" fmla="val 21053"/>
             </a:avLst>
           </a:prstGeom>
           <a:solidFill>
@@ -6664,8 +6664,8 @@
         </p:nvSpPr>
         <p:spPr>
           <a:xfrm>
-            <a:off x="8577072" y="5193792"/>
-            <a:ext cx="1467612" cy="182880"/>
+            <a:off x="8577072" y="5001768"/>
+            <a:ext cx="935736" cy="173736"/>
           </a:xfrm>
           <a:prstGeom prst="rect">
             <a:avLst/>
@@ -6681,7 +6681,7 @@
               <a:buNone/>
             </a:pPr>
             <a:r>
-              <a:rPr lang="en-US" sz="750" b="1" dirty="0">
+              <a:rPr lang="en-US" sz="700" b="1" dirty="0">
                 <a:solidFill>
                   <a:srgbClr val="1C5CAB"/>
                 </a:solidFill>
@@ -6691,7 +6691,7 @@
               </a:rPr>
               <a:t>Reguladores Financieros</a:t>
             </a:r>
-            <a:endParaRPr lang="en-US" sz="750" dirty="0"/>
+            <a:endParaRPr lang="en-US" sz="700" dirty="0"/>
           </a:p>
         </p:txBody>
       </p:sp>
@@ -6703,12 +6703,12 @@
         </p:nvSpPr>
         <p:spPr>
           <a:xfrm>
-            <a:off x="10136124" y="5193792"/>
-            <a:ext cx="1577340" cy="182880"/>
+            <a:off x="9595104" y="5001768"/>
+            <a:ext cx="1045464" cy="173736"/>
           </a:xfrm>
           <a:prstGeom prst="roundRect">
             <a:avLst>
-              <a:gd name="adj" fmla="val 20000"/>
+              <a:gd name="adj" fmla="val 21053"/>
             </a:avLst>
           </a:prstGeom>
           <a:solidFill>
@@ -6730,8 +6730,8 @@
         </p:nvSpPr>
         <p:spPr>
           <a:xfrm>
-            <a:off x="10190988" y="5193792"/>
-            <a:ext cx="1467612" cy="182880"/>
+            <a:off x="9649968" y="5001768"/>
+            <a:ext cx="935736" cy="173736"/>
           </a:xfrm>
           <a:prstGeom prst="rect">
             <a:avLst/>
@@ -6747,7 +6747,7 @@
               <a:buNone/>
             </a:pPr>
             <a:r>
-              <a:rPr lang="en-US" sz="750" b="1" dirty="0">
+              <a:rPr lang="en-US" sz="700" b="1" dirty="0">
                 <a:solidFill>
                   <a:srgbClr val="1C5CAB"/>
                 </a:solidFill>
@@ -6757,7 +6757,7 @@
               </a:rPr>
               <a:t>Reportes Regulatorios</a:t>
             </a:r>
-            <a:endParaRPr lang="en-US" sz="750" dirty="0"/>
+            <a:endParaRPr lang="en-US" sz="700" dirty="0"/>
           </a:p>
         </p:txBody>
       </p:sp>
@@ -6769,12 +6769,12 @@
         </p:nvSpPr>
         <p:spPr>
           <a:xfrm>
-            <a:off x="8522208" y="5413248"/>
-            <a:ext cx="1577340" cy="182880"/>
+            <a:off x="10668000" y="5001768"/>
+            <a:ext cx="1045464" cy="173736"/>
           </a:xfrm>
           <a:prstGeom prst="roundRect">
             <a:avLst>
-              <a:gd name="adj" fmla="val 20000"/>
+              <a:gd name="adj" fmla="val 21053"/>
             </a:avLst>
           </a:prstGeom>
           <a:solidFill>
@@ -6796,8 +6796,8 @@
         </p:nvSpPr>
         <p:spPr>
           <a:xfrm>
-            <a:off x="8577072" y="5413248"/>
-            <a:ext cx="1467612" cy="182880"/>
+            <a:off x="10722864" y="5001768"/>
+            <a:ext cx="935736" cy="173736"/>
           </a:xfrm>
           <a:prstGeom prst="rect">
             <a:avLst/>
@@ -6813,7 +6813,7 @@
               <a:buNone/>
             </a:pPr>
             <a:r>
-              <a:rPr lang="en-US" sz="750" b="1" dirty="0">
+              <a:rPr lang="en-US" sz="700" b="1" dirty="0">
                 <a:solidFill>
                   <a:srgbClr val="1C5CAB"/>
                 </a:solidFill>
@@ -6823,7 +6823,7 @@
               </a:rPr>
               <a:t>Fiscalía</a:t>
             </a:r>
-            <a:endParaRPr lang="en-US" sz="750" dirty="0"/>
+            <a:endParaRPr lang="en-US" sz="700" dirty="0"/>
           </a:p>
         </p:txBody>
       </p:sp>
@@ -6835,12 +6835,12 @@
         </p:nvSpPr>
         <p:spPr>
           <a:xfrm>
-            <a:off x="10136124" y="5413248"/>
-            <a:ext cx="1577340" cy="182880"/>
+            <a:off x="8522208" y="5202936"/>
+            <a:ext cx="1045464" cy="173736"/>
           </a:xfrm>
           <a:prstGeom prst="roundRect">
             <a:avLst>
-              <a:gd name="adj" fmla="val 20000"/>
+              <a:gd name="adj" fmla="val 21053"/>
             </a:avLst>
           </a:prstGeom>
           <a:solidFill>
@@ -6862,8 +6862,8 @@
         </p:nvSpPr>
         <p:spPr>
           <a:xfrm>
-            <a:off x="10190988" y="5413248"/>
-            <a:ext cx="1467612" cy="182880"/>
+            <a:off x="8577072" y="5202936"/>
+            <a:ext cx="935736" cy="173736"/>
           </a:xfrm>
           <a:prstGeom prst="rect">
             <a:avLst/>
@@ -6879,7 +6879,7 @@
               <a:buNone/>
             </a:pPr>
             <a:r>
-              <a:rPr lang="en-US" sz="750" b="1" dirty="0">
+              <a:rPr lang="en-US" sz="700" b="1" dirty="0">
                 <a:solidFill>
                   <a:srgbClr val="1C5CAB"/>
                 </a:solidFill>
@@ -6889,13 +6889,211 @@
               </a:rPr>
               <a:t>SERNAC</a:t>
             </a:r>
-            <a:endParaRPr lang="en-US" sz="750" dirty="0"/>
+            <a:endParaRPr lang="en-US" sz="700" dirty="0"/>
           </a:p>
         </p:txBody>
       </p:sp>
       <p:sp>
         <p:nvSpPr>
           <p:cNvPr id="180" name="Shape 178"/>
+          <p:cNvSpPr/>
+          <p:nvPr/>
+        </p:nvSpPr>
+        <p:spPr>
+          <a:xfrm>
+            <a:off x="9595104" y="5202936"/>
+            <a:ext cx="1045464" cy="173736"/>
+          </a:xfrm>
+          <a:prstGeom prst="roundRect">
+            <a:avLst>
+              <a:gd name="adj" fmla="val 21053"/>
+            </a:avLst>
+          </a:prstGeom>
+          <a:solidFill>
+            <a:srgbClr val="E4EEFB"/>
+          </a:solidFill>
+          <a:ln w="6350">
+            <a:solidFill>
+              <a:srgbClr val="1C5CAB"/>
+            </a:solidFill>
+            <a:prstDash val="solid"/>
+          </a:ln>
+        </p:spPr>
+      </p:sp>
+      <p:sp>
+        <p:nvSpPr>
+          <p:cNvPr id="181" name="Text 179"/>
+          <p:cNvSpPr txBox="1"/>
+          <p:nvPr/>
+        </p:nvSpPr>
+        <p:spPr>
+          <a:xfrm>
+            <a:off x="9649968" y="5202936"/>
+            <a:ext cx="935736" cy="173736"/>
+          </a:xfrm>
+          <a:prstGeom prst="rect">
+            <a:avLst/>
+          </a:prstGeom>
+          <a:noFill/>
+          <a:ln/>
+        </p:spPr>
+        <p:txBody>
+          <a:bodyPr wrap="square" lIns="0" tIns="0" rIns="0" bIns="0" rtlCol="0" anchor="ctr"/>
+          <a:lstStyle/>
+          <a:p>
+            <a:pPr algn="ctr" indent="0" marL="0">
+              <a:buNone/>
+            </a:pPr>
+            <a:r>
+              <a:rPr lang="en-US" sz="700" b="1" dirty="0">
+                <a:solidFill>
+                  <a:srgbClr val="1C5CAB"/>
+                </a:solidFill>
+                <a:latin typeface="Calibri" pitchFamily="34" charset="0"/>
+                <a:ea typeface="Calibri" pitchFamily="34" charset="-122"/>
+                <a:cs typeface="Calibri" pitchFamily="34" charset="-120"/>
+              </a:rPr>
+              <a:t>SIGIR</a:t>
+            </a:r>
+            <a:endParaRPr lang="en-US" sz="700" dirty="0"/>
+          </a:p>
+        </p:txBody>
+      </p:sp>
+      <p:sp>
+        <p:nvSpPr>
+          <p:cNvPr id="182" name="Shape 180"/>
+          <p:cNvSpPr/>
+          <p:nvPr/>
+        </p:nvSpPr>
+        <p:spPr>
+          <a:xfrm>
+            <a:off x="10668000" y="5202936"/>
+            <a:ext cx="1045464" cy="173736"/>
+          </a:xfrm>
+          <a:prstGeom prst="roundRect">
+            <a:avLst>
+              <a:gd name="adj" fmla="val 21053"/>
+            </a:avLst>
+          </a:prstGeom>
+          <a:solidFill>
+            <a:srgbClr val="E4EEFB"/>
+          </a:solidFill>
+          <a:ln w="6350">
+            <a:solidFill>
+              <a:srgbClr val="1C5CAB"/>
+            </a:solidFill>
+            <a:prstDash val="solid"/>
+          </a:ln>
+        </p:spPr>
+      </p:sp>
+      <p:sp>
+        <p:nvSpPr>
+          <p:cNvPr id="183" name="Text 181"/>
+          <p:cNvSpPr txBox="1"/>
+          <p:nvPr/>
+        </p:nvSpPr>
+        <p:spPr>
+          <a:xfrm>
+            <a:off x="10722864" y="5202936"/>
+            <a:ext cx="935736" cy="173736"/>
+          </a:xfrm>
+          <a:prstGeom prst="rect">
+            <a:avLst/>
+          </a:prstGeom>
+          <a:noFill/>
+          <a:ln/>
+        </p:spPr>
+        <p:txBody>
+          <a:bodyPr wrap="square" lIns="0" tIns="0" rIns="0" bIns="0" rtlCol="0" anchor="ctr"/>
+          <a:lstStyle/>
+          <a:p>
+            <a:pPr algn="ctr" indent="0" marL="0">
+              <a:buNone/>
+            </a:pPr>
+            <a:r>
+              <a:rPr lang="en-US" sz="700" b="1" dirty="0">
+                <a:solidFill>
+                  <a:srgbClr val="1C5CAB"/>
+                </a:solidFill>
+                <a:latin typeface="Calibri" pitchFamily="34" charset="0"/>
+                <a:ea typeface="Calibri" pitchFamily="34" charset="-122"/>
+                <a:cs typeface="Calibri" pitchFamily="34" charset="-120"/>
+              </a:rPr>
+              <a:t>Área Comercial</a:t>
+            </a:r>
+            <a:endParaRPr lang="en-US" sz="700" dirty="0"/>
+          </a:p>
+        </p:txBody>
+      </p:sp>
+      <p:sp>
+        <p:nvSpPr>
+          <p:cNvPr id="184" name="Shape 182"/>
+          <p:cNvSpPr/>
+          <p:nvPr/>
+        </p:nvSpPr>
+        <p:spPr>
+          <a:xfrm>
+            <a:off x="8522208" y="5404104"/>
+            <a:ext cx="1045464" cy="173736"/>
+          </a:xfrm>
+          <a:prstGeom prst="roundRect">
+            <a:avLst>
+              <a:gd name="adj" fmla="val 21053"/>
+            </a:avLst>
+          </a:prstGeom>
+          <a:solidFill>
+            <a:srgbClr val="E4EEFB"/>
+          </a:solidFill>
+          <a:ln w="6350">
+            <a:solidFill>
+              <a:srgbClr val="1C5CAB"/>
+            </a:solidFill>
+            <a:prstDash val="solid"/>
+          </a:ln>
+        </p:spPr>
+      </p:sp>
+      <p:sp>
+        <p:nvSpPr>
+          <p:cNvPr id="185" name="Text 183"/>
+          <p:cNvSpPr txBox="1"/>
+          <p:nvPr/>
+        </p:nvSpPr>
+        <p:spPr>
+          <a:xfrm>
+            <a:off x="8577072" y="5404104"/>
+            <a:ext cx="935736" cy="173736"/>
+          </a:xfrm>
+          <a:prstGeom prst="rect">
+            <a:avLst/>
+          </a:prstGeom>
+          <a:noFill/>
+          <a:ln/>
+        </p:spPr>
+        <p:txBody>
+          <a:bodyPr wrap="square" lIns="0" tIns="0" rIns="0" bIns="0" rtlCol="0" anchor="ctr"/>
+          <a:lstStyle/>
+          <a:p>
+            <a:pPr algn="ctr" indent="0" marL="0">
+              <a:buNone/>
+            </a:pPr>
+            <a:r>
+              <a:rPr lang="en-US" sz="700" b="1" dirty="0">
+                <a:solidFill>
+                  <a:srgbClr val="1C5CAB"/>
+                </a:solidFill>
+                <a:latin typeface="Calibri" pitchFamily="34" charset="0"/>
+                <a:ea typeface="Calibri" pitchFamily="34" charset="-122"/>
+                <a:cs typeface="Calibri" pitchFamily="34" charset="-120"/>
+              </a:rPr>
+              <a:t>Otras inst. financieras</a:t>
+            </a:r>
+            <a:endParaRPr lang="en-US" sz="700" dirty="0"/>
+          </a:p>
+        </p:txBody>
+      </p:sp>
+      <p:sp>
+        <p:nvSpPr>
+          <p:cNvPr id="186" name="Shape 184"/>
           <p:cNvSpPr/>
           <p:nvPr/>
         </p:nvSpPr>
@@ -6922,7 +7120,7 @@
       </p:sp>
       <p:sp>
         <p:nvSpPr>
-          <p:cNvPr id="181" name="Text 179"/>
+          <p:cNvPr id="187" name="Text 185"/>
           <p:cNvSpPr txBox="1"/>
           <p:nvPr/>
         </p:nvSpPr>
@@ -6967,7 +7165,7 @@
                 <a:ea typeface="Calibri" pitchFamily="34" charset="-122"/>
                 <a:cs typeface="Calibri" pitchFamily="34" charset="-120"/>
               </a:rPr>
-              <a:t>Las 15 competencias subieron en promedio 2,2 niveles; las funciones pasaron de 4 a 11, los interlocutores de 3 a 7 y la consecuencia de un error de operativa a legal (Ley 21.680). El rediseño de 2024 dejó pendiente el pesaje de remuneración respecto a responsabilidad.</a:t>
+              <a:t>Las 15 competencias subieron en promedio 2,2 niveles; las funciones pasaron de 4 a 11, los interlocutores de 3 a 10 y la consecuencia de un error de operativa a legal (Ley 21.680). El rediseño de 2024 dejó pendiente el pesaje de remuneración respecto a responsabilidad.</a:t>
             </a:r>
             <a:endParaRPr lang="en-US" sz="900" dirty="0"/>
           </a:p>
@@ -6975,7 +7173,7 @@
       </p:sp>
       <p:sp>
         <p:nvSpPr>
-          <p:cNvPr id="182" name="Text 180"/>
+          <p:cNvPr id="188" name="Text 186"/>
           <p:cNvSpPr txBox="1"/>
           <p:nvPr/>
         </p:nvSpPr>
@@ -7192,7 +7390,7 @@
                 <a:ea typeface="Cambria" pitchFamily="34" charset="-122"/>
                 <a:cs typeface="Cambria" pitchFamily="34" charset="-120"/>
               </a:rPr>
-              <a:t>Analista de Contabilidad de Entrada (Portabilidad Financiera)</a:t>
+              <a:t>Analista de Portabilidad de Entrada</a:t>
             </a:r>
             <a:endParaRPr lang="en-US" sz="750" dirty="0"/>
           </a:p>

</xml_diff>